<commit_message>
added the fact that event type indicate the type of flood
</commit_message>
<xml_diff>
--- a/chapter_04/tables/sed_params.pptx
+++ b/chapter_04/tables/sed_params.pptx
@@ -112,14 +112,33 @@
 </p:presentation>
 </file>
 
-<file path=ppt/revisionInfo.xml><?xml version="1.0" encoding="utf-8"?>
-<p1510:revInfo xmlns:a="http://schemas.openxmlformats.org/drawingml/2006/main" xmlns:r="http://schemas.openxmlformats.org/officeDocument/2006/relationships" xmlns:p1510="http://schemas.microsoft.com/office/powerpoint/2015/10/main">
-  <p1510:revLst>
-    <p1510:client id="{4FE2BEEA-55F3-417A-8FD5-E04C968B28F1}" v="53" dt="2025-05-14T08:11:36.154"/>
-    <p1510:client id="{689AFCE9-4A58-41FA-988E-E597B273A83F}" v="15" dt="2025-05-13T10:48:08.519"/>
-    <p1510:client id="{D58F1A07-BA8B-4797-B15A-A7F4D081AF03}" v="20" dt="2025-05-13T11:03:18.245"/>
-  </p1510:revLst>
-</p1510:revInfo>
+<file path=ppt/changesInfos/changesInfo1.xml><?xml version="1.0" encoding="utf-8"?>
+<pc:chgInfo xmlns:a="http://schemas.openxmlformats.org/drawingml/2006/main" xmlns:r="http://schemas.openxmlformats.org/officeDocument/2006/relationships" xmlns:ac="http://schemas.microsoft.com/office/drawing/2013/main/command" xmlns:pc="http://schemas.microsoft.com/office/powerpoint/2013/main/command">
+  <pc:docChgLst>
+    <pc:chgData name="Fatima Pillosu" userId="a6295d4dc9e22643" providerId="LiveId" clId="{87453732-75AC-4426-B5D3-B7C69C2D4F54}"/>
+    <pc:docChg chg="undo custSel modSld">
+      <pc:chgData name="Fatima Pillosu" userId="a6295d4dc9e22643" providerId="LiveId" clId="{87453732-75AC-4426-B5D3-B7C69C2D4F54}" dt="2026-01-19T13:46:22.391" v="85" actId="20577"/>
+      <pc:docMkLst>
+        <pc:docMk/>
+      </pc:docMkLst>
+      <pc:sldChg chg="modSp mod">
+        <pc:chgData name="Fatima Pillosu" userId="a6295d4dc9e22643" providerId="LiveId" clId="{87453732-75AC-4426-B5D3-B7C69C2D4F54}" dt="2026-01-19T13:46:22.391" v="85" actId="20577"/>
+        <pc:sldMkLst>
+          <pc:docMk/>
+          <pc:sldMk cId="3020345181" sldId="257"/>
+        </pc:sldMkLst>
+        <pc:graphicFrameChg chg="modGraphic">
+          <ac:chgData name="Fatima Pillosu" userId="a6295d4dc9e22643" providerId="LiveId" clId="{87453732-75AC-4426-B5D3-B7C69C2D4F54}" dt="2026-01-19T13:46:22.391" v="85" actId="20577"/>
+          <ac:graphicFrameMkLst>
+            <pc:docMk/>
+            <pc:sldMk cId="3020345181" sldId="257"/>
+            <ac:graphicFrameMk id="3" creationId="{15623DAB-A4E1-DF1C-9B96-E2C1CE9DE49A}"/>
+          </ac:graphicFrameMkLst>
+        </pc:graphicFrameChg>
+      </pc:sldChg>
+    </pc:docChg>
+  </pc:docChgLst>
+</pc:chgInfo>
 </file>
 
 <file path=ppt/slideLayouts/slideLayout1.xml><?xml version="1.0" encoding="utf-8"?>
@@ -253,7 +272,7 @@
           <a:p>
             <a:fld id="{1FB3EBC5-2BAE-4ECB-A995-B52653FE7498}" type="datetimeFigureOut">
               <a:rPr lang="en-GB" smtClean="0"/>
-              <a:t>13/05/2025</a:t>
+              <a:t>19/01/2026</a:t>
             </a:fld>
             <a:endParaRPr lang="en-GB"/>
           </a:p>
@@ -423,7 +442,7 @@
           <a:p>
             <a:fld id="{1FB3EBC5-2BAE-4ECB-A995-B52653FE7498}" type="datetimeFigureOut">
               <a:rPr lang="en-GB" smtClean="0"/>
-              <a:t>13/05/2025</a:t>
+              <a:t>19/01/2026</a:t>
             </a:fld>
             <a:endParaRPr lang="en-GB"/>
           </a:p>
@@ -603,7 +622,7 @@
           <a:p>
             <a:fld id="{1FB3EBC5-2BAE-4ECB-A995-B52653FE7498}" type="datetimeFigureOut">
               <a:rPr lang="en-GB" smtClean="0"/>
-              <a:t>13/05/2025</a:t>
+              <a:t>19/01/2026</a:t>
             </a:fld>
             <a:endParaRPr lang="en-GB"/>
           </a:p>
@@ -773,7 +792,7 @@
           <a:p>
             <a:fld id="{1FB3EBC5-2BAE-4ECB-A995-B52653FE7498}" type="datetimeFigureOut">
               <a:rPr lang="en-GB" smtClean="0"/>
-              <a:t>13/05/2025</a:t>
+              <a:t>19/01/2026</a:t>
             </a:fld>
             <a:endParaRPr lang="en-GB"/>
           </a:p>
@@ -1019,7 +1038,7 @@
           <a:p>
             <a:fld id="{1FB3EBC5-2BAE-4ECB-A995-B52653FE7498}" type="datetimeFigureOut">
               <a:rPr lang="en-GB" smtClean="0"/>
-              <a:t>13/05/2025</a:t>
+              <a:t>19/01/2026</a:t>
             </a:fld>
             <a:endParaRPr lang="en-GB"/>
           </a:p>
@@ -1251,7 +1270,7 @@
           <a:p>
             <a:fld id="{1FB3EBC5-2BAE-4ECB-A995-B52653FE7498}" type="datetimeFigureOut">
               <a:rPr lang="en-GB" smtClean="0"/>
-              <a:t>13/05/2025</a:t>
+              <a:t>19/01/2026</a:t>
             </a:fld>
             <a:endParaRPr lang="en-GB"/>
           </a:p>
@@ -1618,7 +1637,7 @@
           <a:p>
             <a:fld id="{1FB3EBC5-2BAE-4ECB-A995-B52653FE7498}" type="datetimeFigureOut">
               <a:rPr lang="en-GB" smtClean="0"/>
-              <a:t>13/05/2025</a:t>
+              <a:t>19/01/2026</a:t>
             </a:fld>
             <a:endParaRPr lang="en-GB"/>
           </a:p>
@@ -1736,7 +1755,7 @@
           <a:p>
             <a:fld id="{1FB3EBC5-2BAE-4ECB-A995-B52653FE7498}" type="datetimeFigureOut">
               <a:rPr lang="en-GB" smtClean="0"/>
-              <a:t>13/05/2025</a:t>
+              <a:t>19/01/2026</a:t>
             </a:fld>
             <a:endParaRPr lang="en-GB"/>
           </a:p>
@@ -1831,7 +1850,7 @@
           <a:p>
             <a:fld id="{1FB3EBC5-2BAE-4ECB-A995-B52653FE7498}" type="datetimeFigureOut">
               <a:rPr lang="en-GB" smtClean="0"/>
-              <a:t>13/05/2025</a:t>
+              <a:t>19/01/2026</a:t>
             </a:fld>
             <a:endParaRPr lang="en-GB"/>
           </a:p>
@@ -2108,7 +2127,7 @@
           <a:p>
             <a:fld id="{1FB3EBC5-2BAE-4ECB-A995-B52653FE7498}" type="datetimeFigureOut">
               <a:rPr lang="en-GB" smtClean="0"/>
-              <a:t>13/05/2025</a:t>
+              <a:t>19/01/2026</a:t>
             </a:fld>
             <a:endParaRPr lang="en-GB"/>
           </a:p>
@@ -2365,7 +2384,7 @@
           <a:p>
             <a:fld id="{1FB3EBC5-2BAE-4ECB-A995-B52653FE7498}" type="datetimeFigureOut">
               <a:rPr lang="en-GB" smtClean="0"/>
-              <a:t>13/05/2025</a:t>
+              <a:t>19/01/2026</a:t>
             </a:fld>
             <a:endParaRPr lang="en-GB"/>
           </a:p>
@@ -2578,7 +2597,7 @@
           <a:p>
             <a:fld id="{1FB3EBC5-2BAE-4ECB-A995-B52653FE7498}" type="datetimeFigureOut">
               <a:rPr lang="en-GB" smtClean="0"/>
-              <a:t>13/05/2025</a:t>
+              <a:t>19/01/2026</a:t>
             </a:fld>
             <a:endParaRPr lang="en-GB"/>
           </a:p>
@@ -2998,14 +3017,14 @@
           <p:nvPr>
             <p:extLst>
               <p:ext uri="{D42A27DB-BD31-4B8C-83A1-F6EECF244321}">
-                <p14:modId xmlns:p14="http://schemas.microsoft.com/office/powerpoint/2010/main" val="2680477406"/>
+                <p14:modId xmlns:p14="http://schemas.microsoft.com/office/powerpoint/2010/main" val="4108717537"/>
               </p:ext>
             </p:extLst>
           </p:nvPr>
         </p:nvGraphicFramePr>
         <p:xfrm>
           <a:off x="1" y="0"/>
-          <a:ext cx="4140000" cy="5949000"/>
+          <a:ext cx="4140000" cy="6055680"/>
         </p:xfrm>
         <a:graphic>
           <a:graphicData uri="http://schemas.openxmlformats.org/drawingml/2006/table">
@@ -3790,7 +3809,19 @@
                         <a:rPr lang="en-US" sz="700" dirty="0">
                           <a:latin typeface="Avenir Next LT Pro" panose="020B0504020202020204" pitchFamily="34" charset="0"/>
                         </a:rPr>
-                        <a:t>Type of events. The only event types permitted in SED are listed in Table 1 of Section 2.1.1 of the NWS Directive 10-1605.</a:t>
+                        <a:t>Type of events (e.g., riverine or </a:t>
+                      </a:r>
+                      <a:r>
+                        <a:rPr lang="en-US" sz="700">
+                          <a:latin typeface="Avenir Next LT Pro" panose="020B0504020202020204" pitchFamily="34" charset="0"/>
+                        </a:rPr>
+                        <a:t>flash floods). </a:t>
+                      </a:r>
+                      <a:r>
+                        <a:rPr lang="en-US" sz="700" dirty="0">
+                          <a:latin typeface="Avenir Next LT Pro" panose="020B0504020202020204" pitchFamily="34" charset="0"/>
+                        </a:rPr>
+                        <a:t>The only event types permitted in SED are listed in Table 1 of Section 2.1.1 of the NWS Directive 10-1605.</a:t>
                       </a:r>
                       <a:endParaRPr lang="en-GB" sz="700" dirty="0">
                         <a:latin typeface="Avenir Next LT Pro" panose="020B0504020202020204" pitchFamily="34" charset="0"/>

</xml_diff>